<commit_message>
Align Wave 2 materials with V2 settlement limits
</commit_message>
<xml_diff>
--- a/submission/AegisBid-Wave2-v2.pptx
+++ b/submission/AegisBid-Wave2-v2.pptx
@@ -2,19 +2,19 @@
 <file path=ppt/presentation.xml><?xml version="1.0" encoding="utf-8"?>
 <p:presentation xmlns:p="http://schemas.openxmlformats.org/presentationml/2006/main">
   <p:sldMasterIdLst>
-    <p:sldMasterId xmlns:r="http://schemas.openxmlformats.org/officeDocument/2006/relationships" id="2147483648" r:id="Rb0dd7d590a1d4017"/>
+    <p:sldMasterId xmlns:r="http://schemas.openxmlformats.org/officeDocument/2006/relationships" id="2147483648" r:id="R590e7f0d44ed4333"/>
   </p:sldMasterIdLst>
   <p:notesMasterIdLst>
-    <p:notesMasterId xmlns:r="http://schemas.openxmlformats.org/officeDocument/2006/relationships" r:id="R0b4b19df685f456f"/>
+    <p:notesMasterId xmlns:r="http://schemas.openxmlformats.org/officeDocument/2006/relationships" r:id="R40ba13a7901d46c2"/>
   </p:notesMasterIdLst>
   <p:sldIdLst>
-    <p:sldId xmlns:r="http://schemas.openxmlformats.org/officeDocument/2006/relationships" id="256" r:id="R86791e3615264eaf"/>
-    <p:sldId xmlns:r="http://schemas.openxmlformats.org/officeDocument/2006/relationships" id="257" r:id="R4f05ab7b400f43b8"/>
-    <p:sldId xmlns:r="http://schemas.openxmlformats.org/officeDocument/2006/relationships" id="258" r:id="Re1dfb21f929148f1"/>
-    <p:sldId xmlns:r="http://schemas.openxmlformats.org/officeDocument/2006/relationships" id="259" r:id="R788c51492b284770"/>
-    <p:sldId xmlns:r="http://schemas.openxmlformats.org/officeDocument/2006/relationships" id="260" r:id="R7b888a80003d4ed1"/>
-    <p:sldId xmlns:r="http://schemas.openxmlformats.org/officeDocument/2006/relationships" id="261" r:id="Rf379c9fafa154988"/>
-    <p:sldId xmlns:r="http://schemas.openxmlformats.org/officeDocument/2006/relationships" id="262" r:id="Rbb2d434ea0eb42e9"/>
+    <p:sldId xmlns:r="http://schemas.openxmlformats.org/officeDocument/2006/relationships" id="256" r:id="R6e27684b13974654"/>
+    <p:sldId xmlns:r="http://schemas.openxmlformats.org/officeDocument/2006/relationships" id="257" r:id="R894f3b7ef52b4b89"/>
+    <p:sldId xmlns:r="http://schemas.openxmlformats.org/officeDocument/2006/relationships" id="258" r:id="Re5eded2787b2439e"/>
+    <p:sldId xmlns:r="http://schemas.openxmlformats.org/officeDocument/2006/relationships" id="259" r:id="R29c875e4c3c54484"/>
+    <p:sldId xmlns:r="http://schemas.openxmlformats.org/officeDocument/2006/relationships" id="260" r:id="R5f1f8212e79149f3"/>
+    <p:sldId xmlns:r="http://schemas.openxmlformats.org/officeDocument/2006/relationships" id="261" r:id="R72771747c2404553"/>
+    <p:sldId xmlns:r="http://schemas.openxmlformats.org/officeDocument/2006/relationships" id="262" r:id="R687be6b83a274bc8"/>
   </p:sldIdLst>
   <p:sldSz cx="12192000" cy="6858000"/>
   <p:notesSz cx="6858000" cy="9144000"/>
@@ -448,7 +448,7 @@
           <a:lstStyle xmlns:a="http://schemas.openxmlformats.org/drawingml/2006/main"/>
           <a:p xmlns:a="http://schemas.openxmlformats.org/drawingml/2006/main">
             <a:r>
-              <a:t>Project facts from the repository README and docs/MIDNIGHT_INTEGRATION.md. Event: https://app.akindo.io/wave-hacks/jaMZjqPOBsLXvjdG. Add verified team, contact, and demo URL before submission.</a:t>
+              <a:t>Project facts from the repository README and docs/MIDNIGHT_INTEGRATION.md. Match the team, demo, and video details to the current AKINDO entry. The current V2 contract does not prove complete-set optimality.</a:t>
             </a:r>
           </a:p>
         </p:txBody>
@@ -798,7 +798,7 @@
           <a:lstStyle xmlns:a="http://schemas.openxmlformats.org/drawingml/2006/main"/>
           <a:p xmlns:a="http://schemas.openxmlformats.org/drawingml/2006/main">
             <a:r>
-              <a:t>Commands are package.json scripts. The README explains that Compact proving backend compilation was verified on a compatible Azure builder; rerun and preserve fresh output before submission. The static check must not be described as compilation.</a:t>
+              <a:t>The listed commands are package.json scripts. Project notes report an earlier Compact compile on a compatible Azure builder, but no reproducible compiler log is included here. A fresh full compile is required for judging evidence. The static check does not compile the contract and does not test complete-set uniqueness.</a:t>
             </a:r>
           </a:p>
         </p:txBody>
@@ -966,6 +966,7 @@
                 <a:spcPts val="0"/>
               </a:spcAft>
               <a:buNone/>
+              <a:defRPr/>
             </a:lvl1pPr>
             <a:lvl2pPr marL="0" indent="0">
               <a:lnSpc>
@@ -978,6 +979,7 @@
                 <a:spcPts val="0"/>
               </a:spcAft>
               <a:buNone/>
+              <a:defRPr/>
             </a:lvl2pPr>
             <a:lvl3pPr marL="0" indent="0">
               <a:lnSpc>
@@ -990,6 +992,7 @@
                 <a:spcPts val="0"/>
               </a:spcAft>
               <a:buNone/>
+              <a:defRPr/>
             </a:lvl3pPr>
             <a:lvl4pPr marL="0" indent="0">
               <a:lnSpc>
@@ -1002,6 +1005,7 @@
                 <a:spcPts val="0"/>
               </a:spcAft>
               <a:buNone/>
+              <a:defRPr/>
             </a:lvl4pPr>
             <a:lvl5pPr marL="0" indent="0">
               <a:lnSpc>
@@ -1014,6 +1018,7 @@
                 <a:spcPts val="0"/>
               </a:spcAft>
               <a:buNone/>
+              <a:defRPr/>
             </a:lvl5pPr>
             <a:lvl6pPr marL="0" indent="0">
               <a:lnSpc>
@@ -1026,6 +1031,7 @@
                 <a:spcPts val="0"/>
               </a:spcAft>
               <a:buNone/>
+              <a:defRPr/>
             </a:lvl6pPr>
             <a:lvl7pPr marL="0" indent="0">
               <a:lnSpc>
@@ -1038,6 +1044,7 @@
                 <a:spcPts val="0"/>
               </a:spcAft>
               <a:buNone/>
+              <a:defRPr/>
             </a:lvl7pPr>
             <a:lvl8pPr marL="0" indent="0">
               <a:lnSpc>
@@ -1050,6 +1057,7 @@
                 <a:spcPts val="0"/>
               </a:spcAft>
               <a:buNone/>
+              <a:defRPr/>
             </a:lvl8pPr>
             <a:lvl9pPr marL="0" indent="0">
               <a:lnSpc>
@@ -1062,6 +1070,7 @@
                 <a:spcPts val="0"/>
               </a:spcAft>
               <a:buNone/>
+              <a:defRPr/>
             </a:lvl9pPr>
           </a:lstStyle>
           <a:p xmlns:a="http://schemas.openxmlformats.org/drawingml/2006/main"/>
@@ -1123,6 +1132,7 @@
                 <a:spcPts val="0"/>
               </a:spcAft>
               <a:buNone/>
+              <a:defRPr/>
             </a:lvl1pPr>
             <a:lvl2pPr marL="0" indent="0">
               <a:lnSpc>
@@ -1135,6 +1145,7 @@
                 <a:spcPts val="0"/>
               </a:spcAft>
               <a:buNone/>
+              <a:defRPr/>
             </a:lvl2pPr>
             <a:lvl3pPr marL="0" indent="0">
               <a:lnSpc>
@@ -1147,6 +1158,7 @@
                 <a:spcPts val="0"/>
               </a:spcAft>
               <a:buNone/>
+              <a:defRPr/>
             </a:lvl3pPr>
             <a:lvl4pPr marL="0" indent="0">
               <a:lnSpc>
@@ -1159,6 +1171,7 @@
                 <a:spcPts val="0"/>
               </a:spcAft>
               <a:buNone/>
+              <a:defRPr/>
             </a:lvl4pPr>
             <a:lvl5pPr marL="0" indent="0">
               <a:lnSpc>
@@ -1171,6 +1184,7 @@
                 <a:spcPts val="0"/>
               </a:spcAft>
               <a:buNone/>
+              <a:defRPr/>
             </a:lvl5pPr>
             <a:lvl6pPr marL="0" indent="0">
               <a:lnSpc>
@@ -1183,6 +1197,7 @@
                 <a:spcPts val="0"/>
               </a:spcAft>
               <a:buNone/>
+              <a:defRPr/>
             </a:lvl6pPr>
             <a:lvl7pPr marL="0" indent="0">
               <a:lnSpc>
@@ -1195,6 +1210,7 @@
                 <a:spcPts val="0"/>
               </a:spcAft>
               <a:buNone/>
+              <a:defRPr/>
             </a:lvl7pPr>
             <a:lvl8pPr marL="0" indent="0">
               <a:lnSpc>
@@ -1207,6 +1223,7 @@
                 <a:spcPts val="0"/>
               </a:spcAft>
               <a:buNone/>
+              <a:defRPr/>
             </a:lvl8pPr>
             <a:lvl9pPr marL="0" indent="0">
               <a:lnSpc>
@@ -1219,6 +1236,7 @@
                 <a:spcPts val="0"/>
               </a:spcAft>
               <a:buNone/>
+              <a:defRPr/>
             </a:lvl9pPr>
           </a:lstStyle>
           <a:p xmlns:a="http://schemas.openxmlformats.org/drawingml/2006/main"/>
@@ -1297,6 +1315,7 @@
                 <a:spcPts val="0"/>
               </a:spcAft>
               <a:buNone/>
+              <a:defRPr/>
             </a:lvl1pPr>
             <a:lvl2pPr marL="0" indent="0">
               <a:lnSpc>
@@ -1309,6 +1328,7 @@
                 <a:spcPts val="0"/>
               </a:spcAft>
               <a:buNone/>
+              <a:defRPr/>
             </a:lvl2pPr>
             <a:lvl3pPr marL="0" indent="0">
               <a:lnSpc>
@@ -1321,6 +1341,7 @@
                 <a:spcPts val="0"/>
               </a:spcAft>
               <a:buNone/>
+              <a:defRPr/>
             </a:lvl3pPr>
             <a:lvl4pPr marL="0" indent="0">
               <a:lnSpc>
@@ -1333,6 +1354,7 @@
                 <a:spcPts val="0"/>
               </a:spcAft>
               <a:buNone/>
+              <a:defRPr/>
             </a:lvl4pPr>
             <a:lvl5pPr marL="0" indent="0">
               <a:lnSpc>
@@ -1345,6 +1367,7 @@
                 <a:spcPts val="0"/>
               </a:spcAft>
               <a:buNone/>
+              <a:defRPr/>
             </a:lvl5pPr>
             <a:lvl6pPr marL="0" indent="0">
               <a:lnSpc>
@@ -1357,6 +1380,7 @@
                 <a:spcPts val="0"/>
               </a:spcAft>
               <a:buNone/>
+              <a:defRPr/>
             </a:lvl6pPr>
             <a:lvl7pPr marL="0" indent="0">
               <a:lnSpc>
@@ -1369,6 +1393,7 @@
                 <a:spcPts val="0"/>
               </a:spcAft>
               <a:buNone/>
+              <a:defRPr/>
             </a:lvl7pPr>
             <a:lvl8pPr marL="0" indent="0">
               <a:lnSpc>
@@ -1381,6 +1406,7 @@
                 <a:spcPts val="0"/>
               </a:spcAft>
               <a:buNone/>
+              <a:defRPr/>
             </a:lvl8pPr>
             <a:lvl9pPr marL="0" indent="0">
               <a:lnSpc>
@@ -1393,6 +1419,7 @@
                 <a:spcPts val="0"/>
               </a:spcAft>
               <a:buNone/>
+              <a:defRPr/>
             </a:lvl9pPr>
           </a:lstStyle>
           <a:p xmlns:a="http://schemas.openxmlformats.org/drawingml/2006/main"/>
@@ -1471,6 +1498,7 @@
                 <a:spcPts val="0"/>
               </a:spcAft>
               <a:buNone/>
+              <a:defRPr/>
             </a:lvl1pPr>
             <a:lvl2pPr marL="0" indent="0">
               <a:lnSpc>
@@ -1483,6 +1511,7 @@
                 <a:spcPts val="0"/>
               </a:spcAft>
               <a:buNone/>
+              <a:defRPr/>
             </a:lvl2pPr>
             <a:lvl3pPr marL="0" indent="0">
               <a:lnSpc>
@@ -1495,6 +1524,7 @@
                 <a:spcPts val="0"/>
               </a:spcAft>
               <a:buNone/>
+              <a:defRPr/>
             </a:lvl3pPr>
             <a:lvl4pPr marL="0" indent="0">
               <a:lnSpc>
@@ -1507,6 +1537,7 @@
                 <a:spcPts val="0"/>
               </a:spcAft>
               <a:buNone/>
+              <a:defRPr/>
             </a:lvl4pPr>
             <a:lvl5pPr marL="0" indent="0">
               <a:lnSpc>
@@ -1519,6 +1550,7 @@
                 <a:spcPts val="0"/>
               </a:spcAft>
               <a:buNone/>
+              <a:defRPr/>
             </a:lvl5pPr>
             <a:lvl6pPr marL="0" indent="0">
               <a:lnSpc>
@@ -1531,6 +1563,7 @@
                 <a:spcPts val="0"/>
               </a:spcAft>
               <a:buNone/>
+              <a:defRPr/>
             </a:lvl6pPr>
             <a:lvl7pPr marL="0" indent="0">
               <a:lnSpc>
@@ -1543,6 +1576,7 @@
                 <a:spcPts val="0"/>
               </a:spcAft>
               <a:buNone/>
+              <a:defRPr/>
             </a:lvl7pPr>
             <a:lvl8pPr marL="0" indent="0">
               <a:lnSpc>
@@ -1555,6 +1589,7 @@
                 <a:spcPts val="0"/>
               </a:spcAft>
               <a:buNone/>
+              <a:defRPr/>
             </a:lvl8pPr>
             <a:lvl9pPr marL="0" indent="0">
               <a:lnSpc>
@@ -1567,6 +1602,7 @@
                 <a:spcPts val="0"/>
               </a:spcAft>
               <a:buNone/>
+              <a:defRPr/>
             </a:lvl9pPr>
           </a:lstStyle>
           <a:p xmlns:a="http://schemas.openxmlformats.org/drawingml/2006/main"/>
@@ -1628,6 +1664,7 @@
                 <a:spcPts val="1200"/>
               </a:spcAft>
               <a:buChar char="•"/>
+              <a:defRPr/>
             </a:lvl1pPr>
             <a:lvl2pPr marL="533400" indent="-228600">
               <a:lnSpc>
@@ -1640,6 +1677,7 @@
                 <a:spcPts val="1200"/>
               </a:spcAft>
               <a:buChar char="•"/>
+              <a:defRPr/>
             </a:lvl2pPr>
             <a:lvl3pPr marL="838200" indent="-228600">
               <a:lnSpc>
@@ -1652,6 +1690,7 @@
                 <a:spcPts val="1200"/>
               </a:spcAft>
               <a:buChar char="•"/>
+              <a:defRPr/>
             </a:lvl3pPr>
             <a:lvl4pPr marL="1143000" indent="-228600">
               <a:lnSpc>
@@ -1664,6 +1703,7 @@
                 <a:spcPts val="1200"/>
               </a:spcAft>
               <a:buChar char="•"/>
+              <a:defRPr/>
             </a:lvl4pPr>
             <a:lvl5pPr marL="1447800" indent="-228600">
               <a:lnSpc>
@@ -1676,6 +1716,7 @@
                 <a:spcPts val="1200"/>
               </a:spcAft>
               <a:buChar char="•"/>
+              <a:defRPr/>
             </a:lvl5pPr>
             <a:lvl6pPr marL="1752600" indent="-228600">
               <a:lnSpc>
@@ -1688,6 +1729,7 @@
                 <a:spcPts val="1200"/>
               </a:spcAft>
               <a:buChar char="•"/>
+              <a:defRPr/>
             </a:lvl6pPr>
             <a:lvl7pPr marL="2057400" indent="-228600">
               <a:lnSpc>
@@ -1700,6 +1742,7 @@
                 <a:spcPts val="1200"/>
               </a:spcAft>
               <a:buChar char="•"/>
+              <a:defRPr/>
             </a:lvl7pPr>
             <a:lvl8pPr marL="2362200" indent="-228600">
               <a:lnSpc>
@@ -1712,6 +1755,7 @@
                 <a:spcPts val="1200"/>
               </a:spcAft>
               <a:buChar char="•"/>
+              <a:defRPr/>
             </a:lvl8pPr>
             <a:lvl9pPr marL="2667000" indent="-228600">
               <a:lnSpc>
@@ -1724,6 +1768,7 @@
                 <a:spcPts val="1200"/>
               </a:spcAft>
               <a:buChar char="•"/>
+              <a:defRPr/>
             </a:lvl9pPr>
           </a:lstStyle>
           <a:p xmlns:a="http://schemas.openxmlformats.org/drawingml/2006/main"/>
@@ -1802,6 +1847,7 @@
                 <a:spcPts val="0"/>
               </a:spcAft>
               <a:buNone/>
+              <a:defRPr/>
             </a:lvl1pPr>
             <a:lvl2pPr marL="0" indent="0">
               <a:lnSpc>
@@ -1814,6 +1860,7 @@
                 <a:spcPts val="0"/>
               </a:spcAft>
               <a:buNone/>
+              <a:defRPr/>
             </a:lvl2pPr>
             <a:lvl3pPr marL="0" indent="0">
               <a:lnSpc>
@@ -1826,6 +1873,7 @@
                 <a:spcPts val="0"/>
               </a:spcAft>
               <a:buNone/>
+              <a:defRPr/>
             </a:lvl3pPr>
             <a:lvl4pPr marL="0" indent="0">
               <a:lnSpc>
@@ -1838,6 +1886,7 @@
                 <a:spcPts val="0"/>
               </a:spcAft>
               <a:buNone/>
+              <a:defRPr/>
             </a:lvl4pPr>
             <a:lvl5pPr marL="0" indent="0">
               <a:lnSpc>
@@ -1850,6 +1899,7 @@
                 <a:spcPts val="0"/>
               </a:spcAft>
               <a:buNone/>
+              <a:defRPr/>
             </a:lvl5pPr>
             <a:lvl6pPr marL="0" indent="0">
               <a:lnSpc>
@@ -1862,6 +1912,7 @@
                 <a:spcPts val="0"/>
               </a:spcAft>
               <a:buNone/>
+              <a:defRPr/>
             </a:lvl6pPr>
             <a:lvl7pPr marL="0" indent="0">
               <a:lnSpc>
@@ -1874,6 +1925,7 @@
                 <a:spcPts val="0"/>
               </a:spcAft>
               <a:buNone/>
+              <a:defRPr/>
             </a:lvl7pPr>
             <a:lvl8pPr marL="0" indent="0">
               <a:lnSpc>
@@ -1886,6 +1938,7 @@
                 <a:spcPts val="0"/>
               </a:spcAft>
               <a:buNone/>
+              <a:defRPr/>
             </a:lvl8pPr>
             <a:lvl9pPr marL="0" indent="0">
               <a:lnSpc>
@@ -1898,6 +1951,7 @@
                 <a:spcPts val="0"/>
               </a:spcAft>
               <a:buNone/>
+              <a:defRPr/>
             </a:lvl9pPr>
           </a:lstStyle>
           <a:p xmlns:a="http://schemas.openxmlformats.org/drawingml/2006/main"/>
@@ -1959,6 +2013,7 @@
                 <a:spcPts val="1200"/>
               </a:spcAft>
               <a:buChar char="•"/>
+              <a:defRPr/>
             </a:lvl1pPr>
             <a:lvl2pPr marL="533400" indent="-228600">
               <a:lnSpc>
@@ -1971,6 +2026,7 @@
                 <a:spcPts val="1200"/>
               </a:spcAft>
               <a:buChar char="•"/>
+              <a:defRPr/>
             </a:lvl2pPr>
             <a:lvl3pPr marL="838200" indent="-228600">
               <a:lnSpc>
@@ -1983,6 +2039,7 @@
                 <a:spcPts val="1200"/>
               </a:spcAft>
               <a:buChar char="•"/>
+              <a:defRPr/>
             </a:lvl3pPr>
             <a:lvl4pPr marL="1143000" indent="-228600">
               <a:lnSpc>
@@ -1995,6 +2052,7 @@
                 <a:spcPts val="1200"/>
               </a:spcAft>
               <a:buChar char="•"/>
+              <a:defRPr/>
             </a:lvl4pPr>
             <a:lvl5pPr marL="1447800" indent="-228600">
               <a:lnSpc>
@@ -2007,6 +2065,7 @@
                 <a:spcPts val="1200"/>
               </a:spcAft>
               <a:buChar char="•"/>
+              <a:defRPr/>
             </a:lvl5pPr>
             <a:lvl6pPr marL="1752600" indent="-228600">
               <a:lnSpc>
@@ -2019,6 +2078,7 @@
                 <a:spcPts val="1200"/>
               </a:spcAft>
               <a:buChar char="•"/>
+              <a:defRPr/>
             </a:lvl6pPr>
             <a:lvl7pPr marL="2057400" indent="-228600">
               <a:lnSpc>
@@ -2031,6 +2091,7 @@
                 <a:spcPts val="1200"/>
               </a:spcAft>
               <a:buChar char="•"/>
+              <a:defRPr/>
             </a:lvl7pPr>
             <a:lvl8pPr marL="2362200" indent="-228600">
               <a:lnSpc>
@@ -2043,6 +2104,7 @@
                 <a:spcPts val="1200"/>
               </a:spcAft>
               <a:buChar char="•"/>
+              <a:defRPr/>
             </a:lvl8pPr>
             <a:lvl9pPr marL="2667000" indent="-228600">
               <a:lnSpc>
@@ -2055,6 +2117,7 @@
                 <a:spcPts val="1200"/>
               </a:spcAft>
               <a:buChar char="•"/>
+              <a:defRPr/>
             </a:lvl9pPr>
           </a:lstStyle>
           <a:p xmlns:a="http://schemas.openxmlformats.org/drawingml/2006/main"/>
@@ -2116,6 +2179,7 @@
                 <a:spcPts val="1200"/>
               </a:spcAft>
               <a:buChar char="•"/>
+              <a:defRPr/>
             </a:lvl1pPr>
             <a:lvl2pPr marL="533400" indent="-228600">
               <a:lnSpc>
@@ -2128,6 +2192,7 @@
                 <a:spcPts val="1200"/>
               </a:spcAft>
               <a:buChar char="•"/>
+              <a:defRPr/>
             </a:lvl2pPr>
             <a:lvl3pPr marL="838200" indent="-228600">
               <a:lnSpc>
@@ -2140,6 +2205,7 @@
                 <a:spcPts val="1200"/>
               </a:spcAft>
               <a:buChar char="•"/>
+              <a:defRPr/>
             </a:lvl3pPr>
             <a:lvl4pPr marL="1143000" indent="-228600">
               <a:lnSpc>
@@ -2152,6 +2218,7 @@
                 <a:spcPts val="1200"/>
               </a:spcAft>
               <a:buChar char="•"/>
+              <a:defRPr/>
             </a:lvl4pPr>
             <a:lvl5pPr marL="1447800" indent="-228600">
               <a:lnSpc>
@@ -2164,6 +2231,7 @@
                 <a:spcPts val="1200"/>
               </a:spcAft>
               <a:buChar char="•"/>
+              <a:defRPr/>
             </a:lvl5pPr>
             <a:lvl6pPr marL="1752600" indent="-228600">
               <a:lnSpc>
@@ -2176,6 +2244,7 @@
                 <a:spcPts val="1200"/>
               </a:spcAft>
               <a:buChar char="•"/>
+              <a:defRPr/>
             </a:lvl6pPr>
             <a:lvl7pPr marL="2057400" indent="-228600">
               <a:lnSpc>
@@ -2188,6 +2257,7 @@
                 <a:spcPts val="1200"/>
               </a:spcAft>
               <a:buChar char="•"/>
+              <a:defRPr/>
             </a:lvl7pPr>
             <a:lvl8pPr marL="2362200" indent="-228600">
               <a:lnSpc>
@@ -2200,6 +2270,7 @@
                 <a:spcPts val="1200"/>
               </a:spcAft>
               <a:buChar char="•"/>
+              <a:defRPr/>
             </a:lvl8pPr>
             <a:lvl9pPr marL="2667000" indent="-228600">
               <a:lnSpc>
@@ -2212,6 +2283,7 @@
                 <a:spcPts val="1200"/>
               </a:spcAft>
               <a:buChar char="•"/>
+              <a:defRPr/>
             </a:lvl9pPr>
           </a:lstStyle>
           <a:p xmlns:a="http://schemas.openxmlformats.org/drawingml/2006/main"/>
@@ -2290,6 +2362,7 @@
                 <a:spcPts val="0"/>
               </a:spcAft>
               <a:buNone/>
+              <a:defRPr/>
             </a:lvl1pPr>
             <a:lvl2pPr marL="0" indent="0">
               <a:lnSpc>
@@ -2302,6 +2375,7 @@
                 <a:spcPts val="0"/>
               </a:spcAft>
               <a:buNone/>
+              <a:defRPr/>
             </a:lvl2pPr>
             <a:lvl3pPr marL="0" indent="0">
               <a:lnSpc>
@@ -2314,6 +2388,7 @@
                 <a:spcPts val="0"/>
               </a:spcAft>
               <a:buNone/>
+              <a:defRPr/>
             </a:lvl3pPr>
             <a:lvl4pPr marL="0" indent="0">
               <a:lnSpc>
@@ -2326,6 +2401,7 @@
                 <a:spcPts val="0"/>
               </a:spcAft>
               <a:buNone/>
+              <a:defRPr/>
             </a:lvl4pPr>
             <a:lvl5pPr marL="0" indent="0">
               <a:lnSpc>
@@ -2338,6 +2414,7 @@
                 <a:spcPts val="0"/>
               </a:spcAft>
               <a:buNone/>
+              <a:defRPr/>
             </a:lvl5pPr>
             <a:lvl6pPr marL="0" indent="0">
               <a:lnSpc>
@@ -2350,6 +2427,7 @@
                 <a:spcPts val="0"/>
               </a:spcAft>
               <a:buNone/>
+              <a:defRPr/>
             </a:lvl6pPr>
             <a:lvl7pPr marL="0" indent="0">
               <a:lnSpc>
@@ -2362,6 +2440,7 @@
                 <a:spcPts val="0"/>
               </a:spcAft>
               <a:buNone/>
+              <a:defRPr/>
             </a:lvl7pPr>
             <a:lvl8pPr marL="0" indent="0">
               <a:lnSpc>
@@ -2374,6 +2453,7 @@
                 <a:spcPts val="0"/>
               </a:spcAft>
               <a:buNone/>
+              <a:defRPr/>
             </a:lvl8pPr>
             <a:lvl9pPr marL="0" indent="0">
               <a:lnSpc>
@@ -2386,6 +2466,7 @@
                 <a:spcPts val="0"/>
               </a:spcAft>
               <a:buNone/>
+              <a:defRPr/>
             </a:lvl9pPr>
           </a:lstStyle>
           <a:p xmlns:a="http://schemas.openxmlformats.org/drawingml/2006/main"/>
@@ -2447,6 +2528,7 @@
                 <a:spcPts val="1200"/>
               </a:spcAft>
               <a:buChar char="•"/>
+              <a:defRPr/>
             </a:lvl1pPr>
             <a:lvl2pPr marL="533400" indent="-228600">
               <a:lnSpc>
@@ -2459,6 +2541,7 @@
                 <a:spcPts val="1200"/>
               </a:spcAft>
               <a:buChar char="•"/>
+              <a:defRPr/>
             </a:lvl2pPr>
             <a:lvl3pPr marL="838200" indent="-228600">
               <a:lnSpc>
@@ -2471,6 +2554,7 @@
                 <a:spcPts val="1200"/>
               </a:spcAft>
               <a:buChar char="•"/>
+              <a:defRPr/>
             </a:lvl3pPr>
             <a:lvl4pPr marL="1143000" indent="-228600">
               <a:lnSpc>
@@ -2483,6 +2567,7 @@
                 <a:spcPts val="1200"/>
               </a:spcAft>
               <a:buChar char="•"/>
+              <a:defRPr/>
             </a:lvl4pPr>
             <a:lvl5pPr marL="1447800" indent="-228600">
               <a:lnSpc>
@@ -2495,6 +2580,7 @@
                 <a:spcPts val="1200"/>
               </a:spcAft>
               <a:buChar char="•"/>
+              <a:defRPr/>
             </a:lvl5pPr>
             <a:lvl6pPr marL="1752600" indent="-228600">
               <a:lnSpc>
@@ -2507,6 +2593,7 @@
                 <a:spcPts val="1200"/>
               </a:spcAft>
               <a:buChar char="•"/>
+              <a:defRPr/>
             </a:lvl6pPr>
             <a:lvl7pPr marL="2057400" indent="-228600">
               <a:lnSpc>
@@ -2519,6 +2606,7 @@
                 <a:spcPts val="1200"/>
               </a:spcAft>
               <a:buChar char="•"/>
+              <a:defRPr/>
             </a:lvl7pPr>
             <a:lvl8pPr marL="2362200" indent="-228600">
               <a:lnSpc>
@@ -2531,6 +2619,7 @@
                 <a:spcPts val="1200"/>
               </a:spcAft>
               <a:buChar char="•"/>
+              <a:defRPr/>
             </a:lvl8pPr>
             <a:lvl9pPr marL="2667000" indent="-228600">
               <a:lnSpc>
@@ -2543,6 +2632,7 @@
                 <a:spcPts val="1200"/>
               </a:spcAft>
               <a:buChar char="•"/>
+              <a:defRPr/>
             </a:lvl9pPr>
           </a:lstStyle>
           <a:p xmlns:a="http://schemas.openxmlformats.org/drawingml/2006/main"/>
@@ -2591,12 +2681,12 @@
   </p:cSld>
   <p:clrMap bg1="lt1" tx1="dk1" bg2="lt2" tx2="dk2" accent1="accent1" accent2="accent2" accent3="accent3" accent4="accent4" accent5="accent5" accent6="accent6" hlink="hlink" folHlink="folHlink"/>
   <p:sldLayoutIdLst>
-    <p:sldLayoutId xmlns:r="http://schemas.openxmlformats.org/officeDocument/2006/relationships" id="2147483649" r:id="Rdef2aa65deb84924"/>
-    <p:sldLayoutId xmlns:r="http://schemas.openxmlformats.org/officeDocument/2006/relationships" id="2147483650" r:id="R67675a1438f54a09"/>
-    <p:sldLayoutId xmlns:r="http://schemas.openxmlformats.org/officeDocument/2006/relationships" id="2147483651" r:id="R18294f8b60ac49c1"/>
-    <p:sldLayoutId xmlns:r="http://schemas.openxmlformats.org/officeDocument/2006/relationships" id="2147483652" r:id="Rd8e6d3dda9834c1b"/>
-    <p:sldLayoutId xmlns:r="http://schemas.openxmlformats.org/officeDocument/2006/relationships" id="2147483653" r:id="R9b047a22a53340f3"/>
-    <p:sldLayoutId xmlns:r="http://schemas.openxmlformats.org/officeDocument/2006/relationships" id="2147483654" r:id="Ra177f9b70f31499c"/>
+    <p:sldLayoutId xmlns:r="http://schemas.openxmlformats.org/officeDocument/2006/relationships" id="2147483649" r:id="R5373e93d60f846bf"/>
+    <p:sldLayoutId xmlns:r="http://schemas.openxmlformats.org/officeDocument/2006/relationships" id="2147483650" r:id="R0fe1928ae962423a"/>
+    <p:sldLayoutId xmlns:r="http://schemas.openxmlformats.org/officeDocument/2006/relationships" id="2147483651" r:id="R4f9e793fa98b4a07"/>
+    <p:sldLayoutId xmlns:r="http://schemas.openxmlformats.org/officeDocument/2006/relationships" id="2147483652" r:id="R7bf07b10107b4902"/>
+    <p:sldLayoutId xmlns:r="http://schemas.openxmlformats.org/officeDocument/2006/relationships" id="2147483653" r:id="R1725d5a627454fdd"/>
+    <p:sldLayoutId xmlns:r="http://schemas.openxmlformats.org/officeDocument/2006/relationships" id="2147483654" r:id="R0498b9e1150f4249"/>
   </p:sldLayoutIdLst>
   <p:txStyles>
     <p:titleStyle>
@@ -3214,6 +3304,7 @@
           </a:lstStyle>
           <a:p xmlns:a="http://schemas.openxmlformats.org/drawingml/2006/main">
             <a:pPr>
+              <a:buNone/>
               <a:defRPr sz="1350" b="1">
                 <a:solidFill>
                   <a:srgbClr val="A9D9F0"/>
@@ -3272,6 +3363,7 @@
           </a:lstStyle>
           <a:p xmlns:a="http://schemas.openxmlformats.org/drawingml/2006/main">
             <a:pPr>
+              <a:buNone/>
               <a:defRPr sz="6450" b="1">
                 <a:solidFill>
                   <a:srgbClr val="FFFFFF"/>
@@ -3330,6 +3422,7 @@
           </a:lstStyle>
           <a:p xmlns:a="http://schemas.openxmlformats.org/drawingml/2006/main">
             <a:pPr>
+              <a:buNone/>
               <a:defRPr sz="3000" b="0">
                 <a:solidFill>
                   <a:srgbClr val="D7EAF6"/>
@@ -3342,11 +3435,12 @@
                   <a:srgbClr val="D7EAF6"/>
                 </a:solidFill>
               </a:rPr>
-              <a:t>Private bids.</a:t>
+              <a:t>Private offers.</a:t>
             </a:r>
           </a:p>
           <a:p xmlns:a="http://schemas.openxmlformats.org/drawingml/2006/main">
             <a:pPr>
+              <a:buNone/>
               <a:defRPr sz="3000" b="0">
                 <a:solidFill>
                   <a:srgbClr val="D7EAF6"/>
@@ -3359,7 +3453,7 @@
                   <a:srgbClr val="D7EAF6"/>
                 </a:solidFill>
               </a:rPr>
-              <a:t>Publicly verifiable outcomes.</a:t>
+              <a:t>A public settlement receipt.</a:t>
             </a:r>
           </a:p>
         </p:txBody>
@@ -3405,6 +3499,7 @@
           </a:lstStyle>
           <a:p xmlns:a="http://schemas.openxmlformats.org/drawingml/2006/main">
             <a:pPr>
+              <a:buNone/>
               <a:defRPr sz="1725" b="0">
                 <a:solidFill>
                   <a:srgbClr val="A9D9F0"/>
@@ -3463,6 +3558,7 @@
           </a:lstStyle>
           <a:p xmlns:a="http://schemas.openxmlformats.org/drawingml/2006/main">
             <a:pPr>
+              <a:buNone/>
               <a:defRPr sz="1200" b="0">
                 <a:solidFill>
                   <a:srgbClr val="B8CAD9"/>
@@ -3550,6 +3646,7 @@
           </a:lstStyle>
           <a:p xmlns:a="http://schemas.openxmlformats.org/drawingml/2006/main">
             <a:pPr>
+              <a:buNone/>
               <a:defRPr sz="1200" b="1">
                 <a:solidFill>
                   <a:srgbClr val="0752A2"/>
@@ -3608,6 +3705,7 @@
           </a:lstStyle>
           <a:p xmlns:a="http://schemas.openxmlformats.org/drawingml/2006/main">
             <a:pPr>
+              <a:buNone/>
               <a:defRPr sz="4050" b="1">
                 <a:solidFill>
                   <a:srgbClr val="0A2444"/>
@@ -3697,6 +3795,7 @@
           </a:lstStyle>
           <a:p xmlns:a="http://schemas.openxmlformats.org/drawingml/2006/main">
             <a:pPr>
+              <a:buNone/>
               <a:defRPr sz="975" b="0">
                 <a:solidFill>
                   <a:srgbClr val="55718D"/>
@@ -3755,6 +3854,7 @@
           </a:lstStyle>
           <a:p xmlns:a="http://schemas.openxmlformats.org/drawingml/2006/main">
             <a:pPr>
+              <a:buNone/>
               <a:defRPr sz="975" b="1">
                 <a:solidFill>
                   <a:srgbClr val="55718D"/>
@@ -3813,6 +3913,7 @@
           </a:lstStyle>
           <a:p xmlns:a="http://schemas.openxmlformats.org/drawingml/2006/main">
             <a:pPr>
+              <a:buNone/>
               <a:defRPr sz="1350" b="1">
                 <a:solidFill>
                   <a:srgbClr val="0752A2"/>
@@ -3871,6 +3972,7 @@
           </a:lstStyle>
           <a:p xmlns:a="http://schemas.openxmlformats.org/drawingml/2006/main">
             <a:pPr>
+              <a:buNone/>
               <a:defRPr sz="2025" b="0">
                 <a:solidFill>
                   <a:srgbClr val="0A2444"/>
@@ -3893,6 +3995,7 @@
           </a:p>
           <a:p xmlns:a="http://schemas.openxmlformats.org/drawingml/2006/main">
             <a:pPr>
+              <a:buNone/>
               <a:defRPr sz="2025" b="0">
                 <a:solidFill>
                   <a:srgbClr val="0A2444"/>
@@ -3982,6 +4085,7 @@
           </a:lstStyle>
           <a:p xmlns:a="http://schemas.openxmlformats.org/drawingml/2006/main">
             <a:pPr>
+              <a:buNone/>
               <a:defRPr sz="1350" b="1">
                 <a:solidFill>
                   <a:srgbClr val="26A97A"/>
@@ -4040,6 +4144,7 @@
           </a:lstStyle>
           <a:p xmlns:a="http://schemas.openxmlformats.org/drawingml/2006/main">
             <a:pPr>
+              <a:buNone/>
               <a:defRPr sz="2025" b="0">
                 <a:solidFill>
                   <a:srgbClr val="0A2444"/>
@@ -4052,7 +4157,7 @@
                   <a:srgbClr val="0A2444"/>
                 </a:solidFill>
               </a:rPr>
-              <a:t>Bidders commit to offers without publishing their values. After closing, a Compact circuit checks that the declared winner belongs to the committed set and satisfies the tender rule.</a:t>
+              <a:t>Bidders commit to offers without publishing their values. After closing, the Compact circuit checks supplied witnesses against commitments and applies the price rule. V2 does not ensure every committed bid is represented.</a:t>
             </a:r>
           </a:p>
         </p:txBody>
@@ -4098,6 +4203,7 @@
           </a:lstStyle>
           <a:p xmlns:a="http://schemas.openxmlformats.org/drawingml/2006/main">
             <a:pPr>
+              <a:buNone/>
               <a:defRPr sz="1725" b="0">
                 <a:solidFill>
                   <a:srgbClr val="55718D"/>
@@ -4185,6 +4291,7 @@
           </a:lstStyle>
           <a:p xmlns:a="http://schemas.openxmlformats.org/drawingml/2006/main">
             <a:pPr>
+              <a:buNone/>
               <a:defRPr sz="1200" b="1">
                 <a:solidFill>
                   <a:srgbClr val="0752A2"/>
@@ -4243,6 +4350,7 @@
           </a:lstStyle>
           <a:p xmlns:a="http://schemas.openxmlformats.org/drawingml/2006/main">
             <a:pPr>
+              <a:buNone/>
               <a:defRPr sz="4050" b="1">
                 <a:solidFill>
                   <a:srgbClr val="0A2444"/>
@@ -4255,7 +4363,7 @@
                   <a:srgbClr val="0A2444"/>
                 </a:solidFill>
               </a:rPr>
-              <a:t>One tender, four verifiable stages</a:t>
+              <a:t>One tender, four stages</a:t>
             </a:r>
           </a:p>
         </p:txBody>
@@ -4332,6 +4440,7 @@
           </a:lstStyle>
           <a:p xmlns:a="http://schemas.openxmlformats.org/drawingml/2006/main">
             <a:pPr>
+              <a:buNone/>
               <a:defRPr sz="975" b="0">
                 <a:solidFill>
                   <a:srgbClr val="55718D"/>
@@ -4390,6 +4499,7 @@
           </a:lstStyle>
           <a:p xmlns:a="http://schemas.openxmlformats.org/drawingml/2006/main">
             <a:pPr>
+              <a:buNone/>
               <a:defRPr sz="975" b="1">
                 <a:solidFill>
                   <a:srgbClr val="55718D"/>
@@ -4448,6 +4558,7 @@
           </a:lstStyle>
           <a:p xmlns:a="http://schemas.openxmlformats.org/drawingml/2006/main">
             <a:pPr>
+              <a:buNone/>
               <a:defRPr sz="1350" b="1">
                 <a:solidFill>
                   <a:srgbClr val="0752A2"/>
@@ -4506,6 +4617,7 @@
           </a:lstStyle>
           <a:p xmlns:a="http://schemas.openxmlformats.org/drawingml/2006/main">
             <a:pPr>
+              <a:buNone/>
               <a:defRPr sz="1725" b="0">
                 <a:solidFill>
                   <a:srgbClr val="0A2444"/>
@@ -4539,7 +4651,7 @@
         </p:nvSpPr>
         <p:spPr>
           <a:xfrm xmlns:a="http://schemas.openxmlformats.org/drawingml/2006/main">
-            <a:off x="781050" y="3381375"/>
+            <a:off x="781050" y="2724150"/>
             <a:ext cx="2286000" cy="19050"/>
           </a:xfrm>
           <a:prstGeom xmlns:a="http://schemas.openxmlformats.org/drawingml/2006/main" prst="rect">
@@ -4595,6 +4707,7 @@
           </a:lstStyle>
           <a:p xmlns:a="http://schemas.openxmlformats.org/drawingml/2006/main">
             <a:pPr>
+              <a:buNone/>
               <a:defRPr sz="1350" b="1">
                 <a:solidFill>
                   <a:srgbClr val="0752A2"/>
@@ -4653,6 +4766,7 @@
           </a:lstStyle>
           <a:p xmlns:a="http://schemas.openxmlformats.org/drawingml/2006/main">
             <a:pPr>
+              <a:buNone/>
               <a:defRPr sz="1725" b="0">
                 <a:solidFill>
                   <a:srgbClr val="0A2444"/>
@@ -4686,7 +4800,7 @@
         </p:nvSpPr>
         <p:spPr>
           <a:xfrm xmlns:a="http://schemas.openxmlformats.org/drawingml/2006/main">
-            <a:off x="3476625" y="3381375"/>
+            <a:off x="3476625" y="2724150"/>
             <a:ext cx="2286000" cy="19050"/>
           </a:xfrm>
           <a:prstGeom xmlns:a="http://schemas.openxmlformats.org/drawingml/2006/main" prst="rect">
@@ -4742,6 +4856,7 @@
           </a:lstStyle>
           <a:p xmlns:a="http://schemas.openxmlformats.org/drawingml/2006/main">
             <a:pPr>
+              <a:buNone/>
               <a:defRPr sz="1350" b="1">
                 <a:solidFill>
                   <a:srgbClr val="0752A2"/>
@@ -4800,6 +4915,7 @@
           </a:lstStyle>
           <a:p xmlns:a="http://schemas.openxmlformats.org/drawingml/2006/main">
             <a:pPr>
+              <a:buNone/>
               <a:defRPr sz="1725" b="0">
                 <a:solidFill>
                   <a:srgbClr val="0A2444"/>
@@ -4833,7 +4949,7 @@
         </p:nvSpPr>
         <p:spPr>
           <a:xfrm xmlns:a="http://schemas.openxmlformats.org/drawingml/2006/main">
-            <a:off x="6172200" y="3381375"/>
+            <a:off x="6172200" y="2724150"/>
             <a:ext cx="2286000" cy="19050"/>
           </a:xfrm>
           <a:prstGeom xmlns:a="http://schemas.openxmlformats.org/drawingml/2006/main" prst="rect">
@@ -4889,6 +5005,7 @@
           </a:lstStyle>
           <a:p xmlns:a="http://schemas.openxmlformats.org/drawingml/2006/main">
             <a:pPr>
+              <a:buNone/>
               <a:defRPr sz="1350" b="1">
                 <a:solidFill>
                   <a:srgbClr val="26A97A"/>
@@ -4947,6 +5064,7 @@
           </a:lstStyle>
           <a:p xmlns:a="http://schemas.openxmlformats.org/drawingml/2006/main">
             <a:pPr>
+              <a:buNone/>
               <a:defRPr sz="1725" b="0">
                 <a:solidFill>
                   <a:srgbClr val="0A2444"/>
@@ -4959,7 +5077,7 @@
                   <a:srgbClr val="0A2444"/>
                 </a:solidFill>
               </a:rPr>
-              <a:t>The circuit checks membership, completeness, ordering, and policy before writing the receipt.</a:t>
+              <a:t>V2 checks supplied bids against commitments and compares their values. It does not yet prove that every committed bid appears exactly once, so global optimality is unproven.</a:t>
             </a:r>
           </a:p>
         </p:txBody>
@@ -5005,6 +5123,7 @@
           </a:lstStyle>
           <a:p xmlns:a="http://schemas.openxmlformats.org/drawingml/2006/main">
             <a:pPr>
+              <a:buNone/>
               <a:defRPr sz="1725" b="1">
                 <a:solidFill>
                   <a:srgbClr val="55718D"/>
@@ -5017,7 +5136,7 @@
                   <a:srgbClr val="55718D"/>
                 </a:solidFill>
               </a:rPr>
-              <a:t>The receipt proves the tender outcome. It does not transfer goods, an award, or payment.</a:t>
+              <a:t>The receipt reveals the selected value. V2 does not yet prove that it is the true optimum.</a:t>
             </a:r>
           </a:p>
         </p:txBody>
@@ -5092,6 +5211,7 @@
           </a:lstStyle>
           <a:p xmlns:a="http://schemas.openxmlformats.org/drawingml/2006/main">
             <a:pPr>
+              <a:buNone/>
               <a:defRPr sz="1200" b="1">
                 <a:solidFill>
                   <a:srgbClr val="0752A2"/>
@@ -5150,6 +5270,7 @@
           </a:lstStyle>
           <a:p xmlns:a="http://schemas.openxmlformats.org/drawingml/2006/main">
             <a:pPr>
+              <a:buNone/>
               <a:defRPr sz="4050" b="1">
                 <a:solidFill>
                   <a:srgbClr val="0A2444"/>
@@ -5162,7 +5283,7 @@
                   <a:srgbClr val="0A2444"/>
                 </a:solidFill>
               </a:rPr>
-              <a:t>What stays private, what the receipt proves</a:t>
+              <a:t>Public state and private witnesses</a:t>
             </a:r>
           </a:p>
         </p:txBody>
@@ -5239,6 +5360,7 @@
           </a:lstStyle>
           <a:p xmlns:a="http://schemas.openxmlformats.org/drawingml/2006/main">
             <a:pPr>
+              <a:buNone/>
               <a:defRPr sz="975" b="0">
                 <a:solidFill>
                   <a:srgbClr val="55718D"/>
@@ -5297,6 +5419,7 @@
           </a:lstStyle>
           <a:p xmlns:a="http://schemas.openxmlformats.org/drawingml/2006/main">
             <a:pPr>
+              <a:buNone/>
               <a:defRPr sz="975" b="1">
                 <a:solidFill>
                   <a:srgbClr val="55718D"/>
@@ -5355,6 +5478,7 @@
           </a:lstStyle>
           <a:p xmlns:a="http://schemas.openxmlformats.org/drawingml/2006/main">
             <a:pPr>
+              <a:buNone/>
               <a:defRPr sz="1350" b="1">
                 <a:solidFill>
                   <a:srgbClr val="0752A2"/>
@@ -5413,6 +5537,7 @@
           </a:lstStyle>
           <a:p xmlns:a="http://schemas.openxmlformats.org/drawingml/2006/main">
             <a:pPr>
+              <a:buNone/>
               <a:defRPr sz="1875" b="0">
                 <a:solidFill>
                   <a:srgbClr val="0A2444"/>
@@ -5430,6 +5555,7 @@
           </a:p>
           <a:p xmlns:a="http://schemas.openxmlformats.org/drawingml/2006/main">
             <a:pPr>
+              <a:buNone/>
               <a:defRPr sz="1875" b="0">
                 <a:solidFill>
                   <a:srgbClr val="0A2444"/>
@@ -5447,6 +5573,7 @@
           </a:p>
           <a:p xmlns:a="http://schemas.openxmlformats.org/drawingml/2006/main">
             <a:pPr>
+              <a:buNone/>
               <a:defRPr sz="1875" b="0">
                 <a:solidFill>
                   <a:srgbClr val="0A2444"/>
@@ -5464,6 +5591,7 @@
           </a:p>
           <a:p xmlns:a="http://schemas.openxmlformats.org/drawingml/2006/main">
             <a:pPr>
+              <a:buNone/>
               <a:defRPr sz="1875" b="0">
                 <a:solidFill>
                   <a:srgbClr val="0A2444"/>
@@ -5481,6 +5609,7 @@
           </a:p>
           <a:p xmlns:a="http://schemas.openxmlformats.org/drawingml/2006/main">
             <a:pPr>
+              <a:buNone/>
               <a:defRPr sz="1875" b="0">
                 <a:solidFill>
                   <a:srgbClr val="0A2444"/>
@@ -5570,6 +5699,7 @@
           </a:lstStyle>
           <a:p xmlns:a="http://schemas.openxmlformats.org/drawingml/2006/main">
             <a:pPr>
+              <a:buNone/>
               <a:defRPr sz="1350" b="1">
                 <a:solidFill>
                   <a:srgbClr val="26A97A"/>
@@ -5628,6 +5758,7 @@
           </a:lstStyle>
           <a:p xmlns:a="http://schemas.openxmlformats.org/drawingml/2006/main">
             <a:pPr>
+              <a:buNone/>
               <a:defRPr sz="1875" b="0">
                 <a:solidFill>
                   <a:srgbClr val="0A2444"/>
@@ -5645,6 +5776,7 @@
           </a:p>
           <a:p xmlns:a="http://schemas.openxmlformats.org/drawingml/2006/main">
             <a:pPr>
+              <a:buNone/>
               <a:defRPr sz="1875" b="0">
                 <a:solidFill>
                   <a:srgbClr val="0A2444"/>
@@ -5662,6 +5794,7 @@
           </a:p>
           <a:p xmlns:a="http://schemas.openxmlformats.org/drawingml/2006/main">
             <a:pPr>
+              <a:buNone/>
               <a:defRPr sz="1875" b="0">
                 <a:solidFill>
                   <a:srgbClr val="0A2444"/>
@@ -5679,6 +5812,7 @@
           </a:p>
           <a:p xmlns:a="http://schemas.openxmlformats.org/drawingml/2006/main">
             <a:pPr>
+              <a:buNone/>
               <a:defRPr sz="1875" b="0">
                 <a:solidFill>
                   <a:srgbClr val="0A2444"/>
@@ -5737,6 +5871,7 @@
           </a:lstStyle>
           <a:p xmlns:a="http://schemas.openxmlformats.org/drawingml/2006/main">
             <a:pPr>
+              <a:buNone/>
               <a:defRPr sz="1650" b="0">
                 <a:solidFill>
                   <a:srgbClr val="55718D"/>
@@ -5824,6 +5959,7 @@
           </a:lstStyle>
           <a:p xmlns:a="http://schemas.openxmlformats.org/drawingml/2006/main">
             <a:pPr>
+              <a:buNone/>
               <a:defRPr sz="1200" b="1">
                 <a:solidFill>
                   <a:srgbClr val="0752A2"/>
@@ -5882,6 +6018,7 @@
           </a:lstStyle>
           <a:p xmlns:a="http://schemas.openxmlformats.org/drawingml/2006/main">
             <a:pPr>
+              <a:buNone/>
               <a:defRPr sz="4050" b="1">
                 <a:solidFill>
                   <a:srgbClr val="0A2444"/>
@@ -5971,6 +6108,7 @@
           </a:lstStyle>
           <a:p xmlns:a="http://schemas.openxmlformats.org/drawingml/2006/main">
             <a:pPr>
+              <a:buNone/>
               <a:defRPr sz="975" b="0">
                 <a:solidFill>
                   <a:srgbClr val="55718D"/>
@@ -6029,6 +6167,7 @@
           </a:lstStyle>
           <a:p xmlns:a="http://schemas.openxmlformats.org/drawingml/2006/main">
             <a:pPr>
+              <a:buNone/>
               <a:defRPr sz="975" b="1">
                 <a:solidFill>
                   <a:srgbClr val="55718D"/>
@@ -6087,6 +6226,7 @@
           </a:lstStyle>
           <a:p xmlns:a="http://schemas.openxmlformats.org/drawingml/2006/main">
             <a:pPr>
+              <a:buNone/>
               <a:defRPr sz="2700" b="1">
                 <a:solidFill>
                   <a:srgbClr val="0752A2"/>
@@ -6145,6 +6285,7 @@
           </a:lstStyle>
           <a:p xmlns:a="http://schemas.openxmlformats.org/drawingml/2006/main">
             <a:pPr>
+              <a:buNone/>
               <a:defRPr sz="1725" b="0">
                 <a:solidFill>
                   <a:srgbClr val="55718D"/>
@@ -6234,6 +6375,7 @@
           </a:lstStyle>
           <a:p xmlns:a="http://schemas.openxmlformats.org/drawingml/2006/main">
             <a:pPr>
+              <a:buNone/>
               <a:defRPr sz="1875" b="0">
                 <a:solidFill>
                   <a:srgbClr val="0A2444"/>
@@ -6246,7 +6388,7 @@
                   <a:srgbClr val="0A2444"/>
                 </a:solidFill>
               </a:rPr>
-              <a:t>The contract uses ledger block time for closing and evaluation gates. It checks a tender-scoped nullifier, evaluator capability, complete witness set, optimal ordering, and reserve or ceiling. Settlement is bounded to eight bids to keep proof assets practical for this prototype.</a:t>
+              <a:t>The contract uses ledger block time for closing and evaluation. It checks the evaluator capability, bid commitments, and the reserve or ceiling. It compares supplied candidate amounts, but does not require distinct witnesses. A repeated bid can mask an omitted one, so V2 does not prove complete-set optimality. Settlement is bounded to eight bids.</a:t>
             </a:r>
           </a:p>
         </p:txBody>
@@ -6292,6 +6434,7 @@
           </a:lstStyle>
           <a:p xmlns:a="http://schemas.openxmlformats.org/drawingml/2006/main">
             <a:pPr>
+              <a:buNone/>
               <a:defRPr sz="1275" b="0">
                 <a:solidFill>
                   <a:srgbClr val="55718D"/>
@@ -6379,6 +6522,7 @@
           </a:lstStyle>
           <a:p xmlns:a="http://schemas.openxmlformats.org/drawingml/2006/main">
             <a:pPr>
+              <a:buNone/>
               <a:defRPr sz="1200" b="1">
                 <a:solidFill>
                   <a:srgbClr val="0752A2"/>
@@ -6437,6 +6581,7 @@
           </a:lstStyle>
           <a:p xmlns:a="http://schemas.openxmlformats.org/drawingml/2006/main">
             <a:pPr>
+              <a:buNone/>
               <a:defRPr sz="4050" b="1">
                 <a:solidFill>
                   <a:srgbClr val="0A2444"/>
@@ -6449,7 +6594,7 @@
                   <a:srgbClr val="0A2444"/>
                 </a:solidFill>
               </a:rPr>
-              <a:t>Evidence first, with explicit boundaries</a:t>
+              <a:t>Evidence and known limits</a:t>
             </a:r>
           </a:p>
         </p:txBody>
@@ -6526,6 +6671,7 @@
           </a:lstStyle>
           <a:p xmlns:a="http://schemas.openxmlformats.org/drawingml/2006/main">
             <a:pPr>
+              <a:buNone/>
               <a:defRPr sz="975" b="0">
                 <a:solidFill>
                   <a:srgbClr val="55718D"/>
@@ -6584,6 +6730,7 @@
           </a:lstStyle>
           <a:p xmlns:a="http://schemas.openxmlformats.org/drawingml/2006/main">
             <a:pPr>
+              <a:buNone/>
               <a:defRPr sz="975" b="1">
                 <a:solidFill>
                   <a:srgbClr val="55718D"/>
@@ -6642,6 +6789,7 @@
           </a:lstStyle>
           <a:p xmlns:a="http://schemas.openxmlformats.org/drawingml/2006/main">
             <a:pPr>
+              <a:buNone/>
               <a:defRPr sz="1350" b="1">
                 <a:solidFill>
                   <a:srgbClr val="0752A2"/>
@@ -6700,6 +6848,7 @@
           </a:lstStyle>
           <a:p xmlns:a="http://schemas.openxmlformats.org/drawingml/2006/main">
             <a:pPr>
+              <a:buNone/>
               <a:defRPr sz="1875" b="0">
                 <a:solidFill>
                   <a:srgbClr val="0A2444"/>
@@ -6717,6 +6866,7 @@
           </a:p>
           <a:p xmlns:a="http://schemas.openxmlformats.org/drawingml/2006/main">
             <a:pPr>
+              <a:buNone/>
               <a:defRPr sz="1875" b="0">
                 <a:solidFill>
                   <a:srgbClr val="0A2444"/>
@@ -6734,6 +6884,7 @@
           </a:p>
           <a:p xmlns:a="http://schemas.openxmlformats.org/drawingml/2006/main">
             <a:pPr>
+              <a:buNone/>
               <a:defRPr sz="1875" b="0">
                 <a:solidFill>
                   <a:srgbClr val="0A2444"/>
@@ -6823,6 +6974,7 @@
           </a:lstStyle>
           <a:p xmlns:a="http://schemas.openxmlformats.org/drawingml/2006/main">
             <a:pPr>
+              <a:buNone/>
               <a:defRPr sz="1350" b="1">
                 <a:solidFill>
                   <a:srgbClr val="26A97A"/>
@@ -6881,6 +7033,7 @@
           </a:lstStyle>
           <a:p xmlns:a="http://schemas.openxmlformats.org/drawingml/2006/main">
             <a:pPr>
+              <a:buNone/>
               <a:defRPr sz="1650" b="0">
                 <a:solidFill>
                   <a:srgbClr val="0A2444"/>
@@ -6898,6 +7051,7 @@
           </a:p>
           <a:p xmlns:a="http://schemas.openxmlformats.org/drawingml/2006/main">
             <a:pPr>
+              <a:buNone/>
               <a:defRPr sz="1650" b="0">
                 <a:solidFill>
                   <a:srgbClr val="0A2444"/>
@@ -6915,6 +7069,7 @@
           </a:p>
           <a:p xmlns:a="http://schemas.openxmlformats.org/drawingml/2006/main">
             <a:pPr>
+              <a:buNone/>
               <a:defRPr sz="1650" b="0">
                 <a:solidFill>
                   <a:srgbClr val="0A2444"/>
@@ -6927,11 +7082,30 @@
                   <a:srgbClr val="0A2444"/>
                 </a:solidFill>
               </a:rPr>
-              <a:t>Evaluator witness handoff needs a trusted channel.</a:t>
+              <a:t>V2 does not require distinct settlement witnesses, so it cannot prove the full set was evaluated or the true optimum selected.</a:t>
             </a:r>
           </a:p>
           <a:p xmlns:a="http://schemas.openxmlformats.org/drawingml/2006/main">
             <a:pPr>
+              <a:buNone/>
+              <a:defRPr sz="1650" b="0">
+                <a:solidFill>
+                  <a:srgbClr val="0A2444"/>
+                </a:solidFill>
+              </a:defRPr>
+            </a:pPr>
+            <a:r>
+              <a:rPr sz="1650" b="0">
+                <a:solidFill>
+                  <a:srgbClr val="0A2444"/>
+                </a:solidFill>
+              </a:rPr>
+              <a:t>Witness handoff needs a trusted channel.</a:t>
+            </a:r>
+          </a:p>
+          <a:p xmlns:a="http://schemas.openxmlformats.org/drawingml/2006/main">
+            <a:pPr>
+              <a:buNone/>
               <a:defRPr sz="1650" b="0">
                 <a:solidFill>
                   <a:srgbClr val="0A2444"/>
@@ -6949,6 +7123,7 @@
           </a:p>
           <a:p xmlns:a="http://schemas.openxmlformats.org/drawingml/2006/main">
             <a:pPr>
+              <a:buNone/>
               <a:defRPr sz="1650" b="0">
                 <a:solidFill>
                   <a:srgbClr val="0A2444"/>
@@ -6961,7 +7136,7 @@
                   <a:srgbClr val="0A2444"/>
                 </a:solidFill>
               </a:rPr>
-              <a:t>No audit. No payment transfer.</a:t>
+              <a:t>No audit or payment transfer.</a:t>
             </a:r>
           </a:p>
         </p:txBody>
@@ -7007,6 +7182,7 @@
           </a:lstStyle>
           <a:p xmlns:a="http://schemas.openxmlformats.org/drawingml/2006/main">
             <a:pPr>
+              <a:buNone/>
               <a:defRPr sz="1575" b="1">
                 <a:solidFill>
                   <a:srgbClr val="55718D"/>
@@ -7094,6 +7270,7 @@
           </a:lstStyle>
           <a:p xmlns:a="http://schemas.openxmlformats.org/drawingml/2006/main">
             <a:pPr>
+              <a:buNone/>
               <a:defRPr sz="1200" b="1">
                 <a:solidFill>
                   <a:srgbClr val="0752A2"/>
@@ -7152,6 +7329,7 @@
           </a:lstStyle>
           <a:p xmlns:a="http://schemas.openxmlformats.org/drawingml/2006/main">
             <a:pPr>
+              <a:buNone/>
               <a:defRPr sz="4050" b="1">
                 <a:solidFill>
                   <a:srgbClr val="0A2444"/>
@@ -7241,6 +7419,7 @@
           </a:lstStyle>
           <a:p xmlns:a="http://schemas.openxmlformats.org/drawingml/2006/main">
             <a:pPr>
+              <a:buNone/>
               <a:defRPr sz="975" b="0">
                 <a:solidFill>
                   <a:srgbClr val="55718D"/>
@@ -7299,6 +7478,7 @@
           </a:lstStyle>
           <a:p xmlns:a="http://schemas.openxmlformats.org/drawingml/2006/main">
             <a:pPr>
+              <a:buNone/>
               <a:defRPr sz="975" b="1">
                 <a:solidFill>
                   <a:srgbClr val="55718D"/>
@@ -7357,6 +7537,7 @@
           </a:lstStyle>
           <a:p xmlns:a="http://schemas.openxmlformats.org/drawingml/2006/main">
             <a:pPr>
+              <a:buNone/>
               <a:defRPr sz="1350" b="1">
                 <a:solidFill>
                   <a:srgbClr val="0752A2"/>
@@ -7415,6 +7596,7 @@
           </a:lstStyle>
           <a:p xmlns:a="http://schemas.openxmlformats.org/drawingml/2006/main">
             <a:pPr>
+              <a:buNone/>
               <a:defRPr sz="2100" b="0">
                 <a:solidFill>
                   <a:srgbClr val="0A2444"/>
@@ -7504,6 +7686,7 @@
           </a:lstStyle>
           <a:p xmlns:a="http://schemas.openxmlformats.org/drawingml/2006/main">
             <a:pPr>
+              <a:buNone/>
               <a:defRPr sz="1350" b="1">
                 <a:solidFill>
                   <a:srgbClr val="26A97A"/>
@@ -7562,6 +7745,7 @@
           </a:lstStyle>
           <a:p xmlns:a="http://schemas.openxmlformats.org/drawingml/2006/main">
             <a:pPr>
+              <a:buNone/>
               <a:defRPr sz="1875" b="0">
                 <a:solidFill>
                   <a:srgbClr val="0A2444"/>
@@ -7620,6 +7804,7 @@
           </a:lstStyle>
           <a:p xmlns:a="http://schemas.openxmlformats.org/drawingml/2006/main">
             <a:pPr>
+              <a:buNone/>
               <a:defRPr sz="1350" b="1">
                 <a:solidFill>
                   <a:srgbClr val="55718D"/>
@@ -7632,7 +7817,7 @@
                   <a:srgbClr val="55718D"/>
                 </a:solidFill>
               </a:rPr>
-              <a:t>AegisBid proves the outcome. The issuer still awards and pays.</a:t>
+              <a:t>AegisBid records a settlement result. The issuer handles award and payment.</a:t>
             </a:r>
           </a:p>
         </p:txBody>

</xml_diff>